<commit_message>
Fix PowerPoint repair error in survey request slides and set school name
Uppercase section GUIDs, drop content-type overrides for missing parts and
empty folder entries; use 山形県立山形南高等学校 as the school name.

Co-Authored-By: Claude Opus 5.5 <noreply@anthropic.com>
Claude-Session: https://claude.ai/code/session_016KgzigKRoFacattySj7Nes
</commit_message>
<xml_diff>
--- a/tankyu/探究_アンケート依頼スライド_サンプル.pptx
+++ b/tankyu/探究_アンケート依頼スライド_サンプル.pptx
@@ -116,7 +116,7 @@
   <p:extLst>
     <p:ext uri="{521415D9-36F7-43E2-AB2F-B90AF26B5E84}">
       <p14:sectionLst xmlns:p14="http://schemas.microsoft.com/office/powerpoint/2010/main">
-        <p14:section name="サンプル：アンケート依頼スライド" id="{41d44061-db2c-bcfe-d9c9-fceb5d64cce0}">
+        <p14:section name="サンプル：アンケート依頼スライド" id="{C2D68052-5B8D-46DE-A192-96F8A6D7A285}">
           <p14:sldIdLst>
             <p14:sldId id="256"/>
             <p14:sldId id="257"/>
@@ -128,7 +128,7 @@
             <p14:sldId id="263"/>
           </p14:sldIdLst>
         </p14:section>
-        <p14:section name="解説（生徒向け）" id="{cf6954df-d7a5-ee46-d2cc-8b22f42e29f9}">
+        <p14:section name="解説（生徒向け）" id="{4EF31262-2B5D-5259-2D7C-89EEF0524AE5}">
           <p14:sldIdLst>
             <p14:sldId id="264"/>
             <p14:sldId id="265"/>
@@ -2548,7 +2548,7 @@
                   <a:schemeClr val="bg1"/>
                 </a:solidFill>
               </a:rPr>
-              <a:t>山形県立○○高等学校 2年　探究チーム「ふるさとラボ」</a:t>
+              <a:t>山形県立山形南高等学校 2年　探究チーム「ふるさとラボ」</a:t>
             </a:r>
             <a:endParaRPr lang="en-US" sz="1400" dirty="0"/>
           </a:p>
@@ -3602,7 +3602,7 @@
                   <a:schemeClr val="tx1"/>
                 </a:solidFill>
               </a:rPr>
-              <a:t>山形県立○○高等学校 2年生 4名</a:t>
+              <a:t>山形県立山形南高等学校 2年生 4名</a:t>
             </a:r>
             <a:endParaRPr lang="en-US" sz="1400" dirty="0"/>
           </a:p>
@@ -7471,7 +7471,7 @@
                   <a:srgbClr val="CFE3E8"/>
                 </a:solidFill>
               </a:rPr>
-              <a:t>お問い合わせ：山形県立○○高等学校　探究担当（○○先生）</a:t>
+              <a:t>お問い合わせ：山形県立山形南高等学校　探究担当（○○先生）</a:t>
             </a:r>
             <a:endParaRPr lang="en-US" sz="1200" dirty="0"/>
           </a:p>

</xml_diff>